<commit_message>
Show vocabulary interface before its calculation slide
</commit_message>
<xml_diff>
--- a/docs/presentation/cohort-pnc-2026-main.pptx
+++ b/docs/presentation/cohort-pnc-2026-main.pptx
@@ -17,8 +17,8 @@
     <p:sldId id="262" r:id="rId8"/>
     <p:sldId id="263" r:id="rId9"/>
     <p:sldId id="264" r:id="rId10"/>
+    <p:sldId id="266" r:id="rId12"/>
     <p:sldId id="265" r:id="rId11"/>
-    <p:sldId id="266" r:id="rId12"/>
     <p:sldId id="267" r:id="rId13"/>
     <p:sldId id="268" r:id="rId14"/>
     <p:sldId id="269" r:id="rId15"/>
@@ -7197,7 +7197,7 @@
               </a:defRPr>
             </a:pPr>
             <a:r>
-              <a:rPr>
+              <a:rPr dirty="0">
                 <a:ea typeface="Microsoft JhengHei"/>
               </a:rPr>
               <a:t>What vocabulary comparison calculates</a:t>
@@ -7294,7 +7294,7 @@
             </a:pPr>
             <a:r>
               <a:rPr lang="en-US" dirty="0"/>
-              <a:t>A list of discriminative strings used to score texts.</a:t>
+              <a:t>Strings counted in target and reference texts.</a:t>
             </a:r>
             <a:endParaRPr dirty="0"/>
           </a:p>
@@ -7774,7 +7774,7 @@
               <a:rPr>
                 <a:ea typeface="Microsoft JhengHei"/>
               </a:rPr>
-              <a:t>10</a:t>
+              <a:t>11</a:t>
             </a:r>
           </a:p>
         </p:txBody>
@@ -8076,7 +8076,7 @@
               <a:rPr>
                 <a:ea typeface="Microsoft JhengHei"/>
               </a:rPr>
-              <a:t>11</a:t>
+              <a:t>10</a:t>
             </a:r>
           </a:p>
         </p:txBody>
@@ -17235,7 +17235,7 @@
         </p:nvSpPr>
         <p:spPr>
           <a:xfrm>
-            <a:off x="952500" y="2381250"/>
+            <a:off x="952500" y="2857500"/>
             <a:ext cx="10287000" cy="1143000"/>
           </a:xfrm>
           <a:prstGeom prst="rect">
@@ -17267,55 +17267,10 @@
               </a:defRPr>
             </a:pPr>
             <a:r>
-              <a:rPr>
+              <a:rPr dirty="0">
                 <a:ea typeface="Microsoft JhengHei"/>
               </a:rPr>
               <a:t>Thank you</a:t>
-            </a:r>
-          </a:p>
-        </p:txBody>
-      </p:sp>
-      <p:sp>
-        <p:nvSpPr>
-          <p:cNvPr id="4" name="TextBox 3"/>
-          <p:cNvSpPr txBox="1"/>
-          <p:nvPr/>
-        </p:nvSpPr>
-        <p:spPr>
-          <a:xfrm>
-            <a:off x="952500" y="3619500"/>
-            <a:ext cx="10287000" cy="571500"/>
-          </a:xfrm>
-          <a:prstGeom prst="rect">
-            <a:avLst/>
-          </a:prstGeom>
-          <a:noFill/>
-        </p:spPr>
-        <p:txBody>
-          <a:bodyPr wrap="square" lIns="0" tIns="0" rIns="0" bIns="0">
-            <a:spAutoFit/>
-          </a:bodyPr>
-          <a:lstStyle/>
-          <a:p>
-            <a:pPr algn="ctr">
-              <a:lnSpc>
-                <a:spcPct val="118000"/>
-              </a:lnSpc>
-              <a:spcBef>
-                <a:spcPts val="0"/>
-              </a:spcBef>
-              <a:spcAft>
-                <a:spcPts val="0"/>
-              </a:spcAft>
-              <a:defRPr sz="2200" b="1">
-                <a:solidFill>
-                  <a:srgbClr val="146C68"/>
-                </a:solidFill>
-                <a:latin typeface="Lato"/>
-              </a:defRPr>
-            </a:pPr>
-            <a:r>
-              <a:t>Cohort · PNC 2026</a:t>
             </a:r>
           </a:p>
         </p:txBody>
@@ -17650,7 +17605,31 @@
               <a:rPr dirty="0">
                 <a:ea typeface="Microsoft JhengHei"/>
               </a:rPr>
-              <a:t>Use Buddhist texts to show the functions,</a:t>
+              <a:t>Use Buddhist texts to show </a:t>
+            </a:r>
+            <a:r>
+              <a:rPr lang="en-US" dirty="0">
+                <a:ea typeface="Microsoft JhengHei"/>
+              </a:rPr>
+              <a:t>its</a:t>
+            </a:r>
+            <a:r>
+              <a:rPr dirty="0">
+                <a:ea typeface="Microsoft JhengHei"/>
+              </a:rPr>
+              <a:t> </a:t>
+            </a:r>
+            <a:r>
+              <a:rPr u="sng" dirty="0">
+                <a:ea typeface="Microsoft JhengHei"/>
+              </a:rPr>
+              <a:t>functions</a:t>
+            </a:r>
+            <a:r>
+              <a:rPr dirty="0">
+                <a:ea typeface="Microsoft JhengHei"/>
+              </a:rPr>
+              <a:t>,</a:t>
             </a:r>
           </a:p>
           <a:p>
@@ -17675,22 +17654,40 @@
               <a:rPr dirty="0">
                 <a:ea typeface="Microsoft JhengHei"/>
               </a:rPr>
-              <a:t>where results can mislead, and the researcher</a:t>
-            </a:r>
-            <a:r>
-              <a:rPr lang="en-US" dirty="0">
+              <a:t>where results can </a:t>
+            </a:r>
+            <a:r>
+              <a:rPr u="sng" dirty="0">
+                <a:ea typeface="Microsoft JhengHei"/>
+              </a:rPr>
+              <a:t>mislead</a:t>
+            </a:r>
+            <a:r>
+              <a:rPr dirty="0">
+                <a:ea typeface="Microsoft JhengHei"/>
+              </a:rPr>
+              <a:t>, and the </a:t>
+            </a:r>
+            <a:r>
+              <a:rPr u="sng" dirty="0">
+                <a:ea typeface="Microsoft JhengHei"/>
+              </a:rPr>
+              <a:t>researcher</a:t>
+            </a:r>
+            <a:r>
+              <a:rPr lang="en-US" u="sng" dirty="0">
                 <a:ea typeface="Microsoft JhengHei"/>
               </a:rPr>
               <a:t>’s</a:t>
             </a:r>
             <a:r>
-              <a:rPr dirty="0">
+              <a:rPr u="sng" dirty="0">
                 <a:ea typeface="Microsoft JhengHei"/>
               </a:rPr>
               <a:t> </a:t>
             </a:r>
             <a:r>
-              <a:rPr lang="en-US" dirty="0">
+              <a:rPr lang="en-US" u="sng" dirty="0">
                 <a:ea typeface="Microsoft JhengHei"/>
               </a:rPr>
               <a:t>role</a:t>
@@ -17883,7 +17880,7 @@
         <p:spPr>
           <a:xfrm>
             <a:off x="495299" y="742950"/>
-            <a:ext cx="11144250" cy="952500"/>
+            <a:ext cx="11144250" cy="523220"/>
           </a:xfrm>
           <a:prstGeom prst="rect">
             <a:avLst/>
@@ -17914,10 +17911,22 @@
               </a:defRPr>
             </a:pPr>
             <a:r>
-              <a:rPr>
-                <a:ea typeface="Microsoft JhengHei"/>
-              </a:rPr>
-              <a:t>Agent support for diachronic research</a:t>
+              <a:rPr dirty="0">
+                <a:ea typeface="Microsoft JhengHei"/>
+              </a:rPr>
+              <a:t>Agent</a:t>
+            </a:r>
+            <a:r>
+              <a:rPr lang="en-US" dirty="0">
+                <a:ea typeface="Microsoft JhengHei"/>
+              </a:rPr>
+              <a:t>ic</a:t>
+            </a:r>
+            <a:r>
+              <a:rPr dirty="0">
+                <a:ea typeface="Microsoft JhengHei"/>
+              </a:rPr>
+              <a:t> support for diachronic research</a:t>
             </a:r>
           </a:p>
         </p:txBody>
@@ -21760,7 +21769,7 @@
         <p:spPr>
           <a:xfrm>
             <a:off x="495299" y="742950"/>
-            <a:ext cx="11144250" cy="1047749"/>
+            <a:ext cx="11144250" cy="457882"/>
           </a:xfrm>
           <a:prstGeom prst="rect">
             <a:avLst/>
@@ -21791,10 +21800,34 @@
               </a:defRPr>
             </a:pPr>
             <a:r>
-              <a:rPr>
-                <a:ea typeface="Microsoft JhengHei"/>
-              </a:rPr>
-              <a:t>Example: related content, little shared wording</a:t>
+              <a:rPr sz="2800" dirty="0">
+                <a:ea typeface="Microsoft JhengHei"/>
+              </a:rPr>
+              <a:t>Example: </a:t>
+            </a:r>
+            <a:r>
+              <a:rPr lang="en-US" sz="2800" dirty="0">
+                <a:ea typeface="Microsoft JhengHei"/>
+              </a:rPr>
+              <a:t>retrieving </a:t>
+            </a:r>
+            <a:r>
+              <a:rPr sz="2800" dirty="0">
+                <a:ea typeface="Microsoft JhengHei"/>
+              </a:rPr>
+              <a:t>related content</a:t>
+            </a:r>
+            <a:r>
+              <a:rPr lang="en-US" sz="2800" dirty="0">
+                <a:ea typeface="Microsoft JhengHei"/>
+              </a:rPr>
+              <a:t> but with </a:t>
+            </a:r>
+            <a:r>
+              <a:rPr sz="2800" dirty="0">
+                <a:ea typeface="Microsoft JhengHei"/>
+              </a:rPr>
+              <a:t>little shared wording</a:t>
             </a:r>
           </a:p>
         </p:txBody>

</xml_diff>